<commit_message>
Translate all code comments, docstrings, and docs to English
Code is verified token-identical via AST comparison. The English demo deck
is now monolingual (script-independent defects only), and README assets are
re-rendered at higher resolution.
</commit_message>
<xml_diff>
--- a/examples/broken.pptx
+++ b/examples/broken.pptx
@@ -3131,6 +3131,40 @@
         </p:nvSpPr>
         <p:spPr>
           <a:xfrm>
+            <a:off x="731520" y="2560320"/>
+            <a:ext cx="5486400" cy="457200"/>
+          </a:xfrm>
+          <a:prstGeom prst="rect">
+            <a:avLst/>
+          </a:prstGeom>
+          <a:noFill/>
+        </p:spPr>
+        <p:txBody>
+          <a:bodyPr wrap="square">
+            <a:spAutoFit/>
+          </a:bodyPr>
+          <a:lstStyle/>
+          <a:p>
+            <a:r>
+              <a:rPr sz="1600" b="0" spc="300">
+                <a:solidFill>
+                  <a:srgbClr val="1A1A1A"/>
+                </a:solidFill>
+                <a:ea typeface="맑은 고딕"/>
+              </a:rPr>
+              <a:t>자간이 벌어진 한글 강조</a:t>
+            </a:r>
+          </a:p>
+        </p:txBody>
+      </p:sp>
+      <p:sp>
+        <p:nvSpPr>
+          <p:cNvPr id="4" name="TextBox 3"/>
+          <p:cNvSpPr txBox="1"/>
+          <p:nvPr/>
+        </p:nvSpPr>
+        <p:spPr>
+          <a:xfrm>
             <a:off x="731520" y="1645920"/>
             <a:ext cx="9144000" cy="548640"/>
           </a:xfrm>
@@ -3153,40 +3187,6 @@
                 <a:ea typeface="맑은 고딕"/>
               </a:rPr>
               <a:t>핵심 지표는 전 분기 대비 개선—특히 구독 매출이 견인했습니다</a:t>
-            </a:r>
-          </a:p>
-        </p:txBody>
-      </p:sp>
-      <p:sp>
-        <p:nvSpPr>
-          <p:cNvPr id="4" name="TextBox 3"/>
-          <p:cNvSpPr txBox="1"/>
-          <p:nvPr/>
-        </p:nvSpPr>
-        <p:spPr>
-          <a:xfrm>
-            <a:off x="731520" y="2560320"/>
-            <a:ext cx="5486400" cy="457200"/>
-          </a:xfrm>
-          <a:prstGeom prst="rect">
-            <a:avLst/>
-          </a:prstGeom>
-          <a:noFill/>
-        </p:spPr>
-        <p:txBody>
-          <a:bodyPr wrap="square">
-            <a:spAutoFit/>
-          </a:bodyPr>
-          <a:lstStyle/>
-          <a:p>
-            <a:r>
-              <a:rPr sz="1600" b="0" spc="300">
-                <a:solidFill>
-                  <a:srgbClr val="1A1A1A"/>
-                </a:solidFill>
-                <a:ea typeface="맑은 고딕"/>
-              </a:rPr>
-              <a:t>자간이 벌어진 한글 강조</a:t>
             </a:r>
           </a:p>
         </p:txBody>

</xml_diff>